<commit_message>
Weekly report: results review moved to Friday Oct 23, form friction review added
Co-Authored-By: Claude Opus 5.5 <noreply@anthropic.com>
Claude-Session: https://claude.ai/code/session_019DhPojZLRqLyCNxgD7HVTj
</commit_message>
<xml_diff>
--- a/build/reports/informes/Informe_Meta_Ads_Orchid_2026-10-19.pptx
+++ b/build/reports/informes/Informe_Meta_Ads_Orchid_2026-10-19.pptx
@@ -120,47 +120,47 @@
   <p:extLst>
     <p:ext uri="{521415D9-36F7-43E2-AB2F-B90AF26B5E84}">
       <p14:sectionLst xmlns:p14="http://schemas.microsoft.com/office/powerpoint/2010/main">
-        <p14:section name="Resumen" id="{6fa92dd3-669d-0950-2e65-828820a88cb3}">
+        <p14:section name="Resumen" id="{9a71f1c0-7cf5-f553-9790-a7e4d8491226}">
           <p14:sldIdLst>
             <p14:sldId id="256"/>
             <p14:sldId id="257"/>
           </p14:sldIdLst>
         </p14:section>
-        <p14:section name="Resultados" id="{548c2184-7d08-2540-d383-debafaeac63a}">
+        <p14:section name="Resultados" id="{3dac0e2e-ad08-8924-ed78-41cd7f527957}">
           <p14:sldIdLst>
             <p14:sldId id="258"/>
             <p14:sldId id="259"/>
           </p14:sldIdLst>
         </p14:section>
-        <p14:section name="Qué hicimos" id="{4db10b56-15b3-6b86-34e3-b965535f59df}">
+        <p14:section name="Qué hicimos" id="{1dba666a-5fb2-bf51-c358-cbb3b60b42be}">
           <p14:sldIdLst>
             <p14:sldId id="260"/>
             <p14:sldId id="261"/>
           </p14:sldIdLst>
         </p14:section>
-        <p14:section name="Aprendizajes" id="{c98838c8-9030-1a74-9f00-5e1f99812270}">
+        <p14:section name="Aprendizajes" id="{0ac2de73-1473-8e04-3457-873b30e9cc99}">
           <p14:sldIdLst>
             <p14:sldId id="262"/>
           </p14:sldIdLst>
         </p14:section>
-        <p14:section name="Anuncios" id="{2c8cfd8c-d1ac-6364-cd88-3d4b77ca056e}">
+        <p14:section name="Anuncios" id="{a9c12623-75f4-1792-151b-7f16d382e8e1}">
           <p14:sldIdLst>
             <p14:sldId id="263"/>
             <p14:sldId id="264"/>
             <p14:sldId id="265"/>
           </p14:sldIdLst>
         </p14:section>
-        <p14:section name="Conclusiones" id="{3d1cb25f-6f58-328d-a64e-9762b3ea4ab1}">
+        <p14:section name="Conclusiones" id="{b333633e-b92a-9b86-4096-9405e2c4377d}">
           <p14:sldIdLst>
             <p14:sldId id="266"/>
           </p14:sldIdLst>
         </p14:section>
-        <p14:section name="Estrategia creativa" id="{fbe80ef3-caca-161e-d3a9-66fce801559f}">
+        <p14:section name="Estrategia creativa" id="{6f3895f6-33fa-7b64-9c6f-9c9227053400}">
           <p14:sldIdLst>
             <p14:sldId id="267"/>
           </p14:sldIdLst>
         </p14:section>
-        <p14:section name="Próximos pasos" id="{923f9b40-7a80-669d-b88c-503364ce8b4a}">
+        <p14:section name="Próximos pasos" id="{72dcde58-93f2-376f-c69b-8ed9a6cb7ed8}">
           <p14:sldIdLst>
             <p14:sldId id="268"/>
             <p14:sldId id="269"/>
@@ -6456,7 +6456,7 @@
                 <a:ea typeface="Cambria" pitchFamily="34" charset="-122"/>
                 <a:cs typeface="Cambria" pitchFamily="34" charset="-120"/>
               </a:rPr>
-              <a:t>Validar la conversión</a:t>
+              <a:t>Formulario con menos fricción</a:t>
             </a:r>
             <a:endParaRPr lang="en-US" sz="1700" dirty="0"/>
           </a:p>
@@ -6492,7 +6492,7 @@
                   <a:schemeClr val="tx1"/>
                 </a:solidFill>
               </a:rPr>
-              <a:t>Envío de prueba del formulario desde el celular. Verificar que llegue a GHL y que Meta registre el evento Lead.</a:t>
+              <a:t>Revisar el formulario de la landing para reducir pasos y campos. Prueba de envío desde el celular: que llegue a GHL y que Meta registre el evento Lead.</a:t>
             </a:r>
             <a:endParaRPr lang="en-US" sz="1300" dirty="0"/>
           </a:p>
@@ -6619,7 +6619,7 @@
                 <a:ea typeface="Cambria" pitchFamily="34" charset="-122"/>
                 <a:cs typeface="Cambria" pitchFamily="34" charset="-120"/>
               </a:rPr>
-              <a:t>Revisión miércoles 21</a:t>
+              <a:t>Resultados el viernes 23</a:t>
             </a:r>
             <a:endParaRPr lang="en-US" sz="1700" dirty="0"/>
           </a:p>
@@ -6655,7 +6655,7 @@
                   <a:schemeClr val="tx1"/>
                 </a:solidFill>
               </a:rPr>
-              <a:t>Criterio de corte: $40 sin lead. Rotación desde la banca (H5, H4). Sin otros cambios hasta entonces.</a:t>
+              <a:t>Anuncios sin cambios hasta el viernes. Criterio de corte: $40 sin lead; rotación desde la banca (H5, H4).</a:t>
             </a:r>
             <a:endParaRPr lang="en-US" sz="1300" dirty="0"/>
           </a:p>

</xml_diff>

<commit_message>
Weekly report: add video ads request to plan and decisions
Co-Authored-By: Claude Opus 5.5 <noreply@anthropic.com>
Claude-Session: https://claude.ai/code/session_019DhPojZLRqLyCNxgD7HVTj
</commit_message>
<xml_diff>
--- a/build/reports/informes/Informe_Meta_Ads_Orchid_2026-10-19.pptx
+++ b/build/reports/informes/Informe_Meta_Ads_Orchid_2026-10-19.pptx
@@ -120,47 +120,47 @@
   <p:extLst>
     <p:ext uri="{521415D9-36F7-43E2-AB2F-B90AF26B5E84}">
       <p14:sectionLst xmlns:p14="http://schemas.microsoft.com/office/powerpoint/2010/main">
-        <p14:section name="Resumen" id="{9a71f1c0-7cf5-f553-9790-a7e4d8491226}">
+        <p14:section name="Resumen" id="{da79f44e-8900-c272-9a5c-ff106dada0a2}">
           <p14:sldIdLst>
             <p14:sldId id="256"/>
             <p14:sldId id="257"/>
           </p14:sldIdLst>
         </p14:section>
-        <p14:section name="Resultados" id="{3dac0e2e-ad08-8924-ed78-41cd7f527957}">
+        <p14:section name="Resultados" id="{2332358b-3e8d-92e4-ee39-ced48abe2dd0}">
           <p14:sldIdLst>
             <p14:sldId id="258"/>
             <p14:sldId id="259"/>
           </p14:sldIdLst>
         </p14:section>
-        <p14:section name="Qué hicimos" id="{1dba666a-5fb2-bf51-c358-cbb3b60b42be}">
+        <p14:section name="Qué hicimos" id="{a8ebe875-5c10-717a-0d6a-16c211fe93da}">
           <p14:sldIdLst>
             <p14:sldId id="260"/>
             <p14:sldId id="261"/>
           </p14:sldIdLst>
         </p14:section>
-        <p14:section name="Aprendizajes" id="{0ac2de73-1473-8e04-3457-873b30e9cc99}">
+        <p14:section name="Aprendizajes" id="{0d161fc3-9342-1995-34eb-177dbc153ee7}">
           <p14:sldIdLst>
             <p14:sldId id="262"/>
           </p14:sldIdLst>
         </p14:section>
-        <p14:section name="Anuncios" id="{a9c12623-75f4-1792-151b-7f16d382e8e1}">
+        <p14:section name="Anuncios" id="{f467d7e7-d2ba-887f-3ee1-75930f73955b}">
           <p14:sldIdLst>
             <p14:sldId id="263"/>
             <p14:sldId id="264"/>
             <p14:sldId id="265"/>
           </p14:sldIdLst>
         </p14:section>
-        <p14:section name="Conclusiones" id="{b333633e-b92a-9b86-4096-9405e2c4377d}">
+        <p14:section name="Conclusiones" id="{e5c28259-6cce-de09-48bb-4830fc479f49}">
           <p14:sldIdLst>
             <p14:sldId id="266"/>
           </p14:sldIdLst>
         </p14:section>
-        <p14:section name="Estrategia creativa" id="{6f3895f6-33fa-7b64-9c6f-9c9227053400}">
+        <p14:section name="Estrategia creativa" id="{88b0b6c1-ac7c-0b56-6bcb-3c0032e60566}">
           <p14:sldIdLst>
             <p14:sldId id="267"/>
           </p14:sldIdLst>
         </p14:section>
-        <p14:section name="Próximos pasos" id="{72dcde58-93f2-376f-c69b-8ed9a6cb7ed8}">
+        <p14:section name="Próximos pasos" id="{4dffb1bc-4810-07e2-375a-2c568c1e6a73}">
           <p14:sldIdLst>
             <p14:sldId id="268"/>
             <p14:sldId id="269"/>
@@ -1330,7 +1330,7 @@
           <a:p>
             <a:r>
               <a:rPr lang="en-US" dirty="0"/>
-              <a:t>Las tres afectan la calidad de los leads más que cualquier ajuste de anuncios.</a:t>
+              <a:t>Siguen pendientes de la semana anterior: CPL calificado objetivo y envío del evento Lead vía CAPI solo para "I want to hire.".</a:t>
             </a:r>
             <a:endParaRPr lang="en-US" dirty="0"/>
           </a:p>
@@ -6782,7 +6782,7 @@
                 <a:ea typeface="Cambria" pitchFamily="34" charset="-122"/>
                 <a:cs typeface="Cambria" pitchFamily="34" charset="-120"/>
               </a:rPr>
-              <a:t>Creativos y página</a:t>
+              <a:t>Anuncios en video</a:t>
             </a:r>
             <a:endParaRPr lang="en-US" sz="1700" dirty="0"/>
           </a:p>
@@ -6818,7 +6818,7 @@
                   <a:schemeClr val="tx1"/>
                 </a:solidFill>
               </a:rPr>
-              <a:t>Cambio de categorías de la página. Pedir a Debi texto en imagen desde la firma y versiones 9:16.</a:t>
+              <a:t>Necesitamos 2–3 videos 9:16 para probar, con un abogado en cámara. El video tuvo CTR 6.2% vs. 1.9% del estático y trajo el único lead calificado (V2).</a:t>
             </a:r>
             <a:endParaRPr lang="en-US" sz="1300" dirty="0"/>
           </a:p>
@@ -7187,7 +7187,7 @@
                   <a:schemeClr val="accent1"/>
                 </a:solidFill>
               </a:rPr>
-              <a:t>Pendientes de la semana anterior</a:t>
+              <a:t>Producción de videos</a:t>
             </a:r>
             <a:endParaRPr lang="en-US" sz="1800" dirty="0"/>
           </a:p>
@@ -7223,7 +7223,7 @@
                   <a:schemeClr val="bg1"/>
                 </a:solidFill>
               </a:rPr>
-              <a:t>CPL calificado objetivo y envío del evento Lead vía CAPI solo para "I want to hire.".</a:t>
+              <a:t>Aprobar 2–3 anuncios en video para el piloto. Hoy solo hay estáticos activos; sin video no podemos probar el formato que mejor ha convertido.</a:t>
             </a:r>
             <a:endParaRPr lang="en-US" sz="1400" dirty="0"/>
           </a:p>

</xml_diff>

<commit_message>
Weekly report: plain slide titles without conclusions
Co-Authored-By: Claude Opus 5.5 <noreply@anthropic.com>
Claude-Session: https://claude.ai/code/session_019DhPojZLRqLyCNxgD7HVTj
</commit_message>
<xml_diff>
--- a/build/reports/informes/Informe_Meta_Ads_Orchid_2026-10-19.pptx
+++ b/build/reports/informes/Informe_Meta_Ads_Orchid_2026-10-19.pptx
@@ -120,47 +120,47 @@
   <p:extLst>
     <p:ext uri="{521415D9-36F7-43E2-AB2F-B90AF26B5E84}">
       <p14:sectionLst xmlns:p14="http://schemas.microsoft.com/office/powerpoint/2010/main">
-        <p14:section name="Resumen" id="{da79f44e-8900-c272-9a5c-ff106dada0a2}">
+        <p14:section name="Resumen" id="{131f9c88-a745-6849-5cb0-2b661b97404d}">
           <p14:sldIdLst>
             <p14:sldId id="256"/>
             <p14:sldId id="257"/>
           </p14:sldIdLst>
         </p14:section>
-        <p14:section name="Resultados" id="{2332358b-3e8d-92e4-ee39-ced48abe2dd0}">
+        <p14:section name="Resultados" id="{3de8f6f9-aa97-6b27-dab5-6457815911e9}">
           <p14:sldIdLst>
             <p14:sldId id="258"/>
             <p14:sldId id="259"/>
           </p14:sldIdLst>
         </p14:section>
-        <p14:section name="Qué hicimos" id="{a8ebe875-5c10-717a-0d6a-16c211fe93da}">
+        <p14:section name="Qué hicimos" id="{710f42cb-6b7d-229a-9203-317b783ac791}">
           <p14:sldIdLst>
             <p14:sldId id="260"/>
             <p14:sldId id="261"/>
           </p14:sldIdLst>
         </p14:section>
-        <p14:section name="Aprendizajes" id="{0d161fc3-9342-1995-34eb-177dbc153ee7}">
+        <p14:section name="Aprendizajes" id="{005faca1-ab7b-c786-b8c9-eacce4adc9a6}">
           <p14:sldIdLst>
             <p14:sldId id="262"/>
           </p14:sldIdLst>
         </p14:section>
-        <p14:section name="Anuncios" id="{f467d7e7-d2ba-887f-3ee1-75930f73955b}">
+        <p14:section name="Anuncios" id="{89224e96-59e3-7849-5974-eaaf5f199571}">
           <p14:sldIdLst>
             <p14:sldId id="263"/>
             <p14:sldId id="264"/>
             <p14:sldId id="265"/>
           </p14:sldIdLst>
         </p14:section>
-        <p14:section name="Conclusiones" id="{e5c28259-6cce-de09-48bb-4830fc479f49}">
+        <p14:section name="Conclusiones" id="{c756ba72-5910-a024-7030-2345d4c008fd}">
           <p14:sldIdLst>
             <p14:sldId id="266"/>
           </p14:sldIdLst>
         </p14:section>
-        <p14:section name="Estrategia creativa" id="{88b0b6c1-ac7c-0b56-6bcb-3c0032e60566}">
+        <p14:section name="Estrategia creativa" id="{ad709303-09b4-5b35-94ba-81be4408b72e}">
           <p14:sldIdLst>
             <p14:sldId id="267"/>
           </p14:sldIdLst>
         </p14:section>
-        <p14:section name="Próximos pasos" id="{4dffb1bc-4810-07e2-375a-2c568c1e6a73}">
+        <p14:section name="Próximos pasos" id="{f6838a82-e8a9-53e0-4954-da7cbbda2e24}">
           <p14:sldIdLst>
             <p14:sldId id="268"/>
             <p14:sldId id="269"/>
@@ -2973,7 +2973,7 @@
                   <a:schemeClr val="tx2"/>
                 </a:solidFill>
               </a:rPr>
-              <a:t>Banca lista: 6 anuncios en pausa</a:t>
+              <a:t>Banca lista</a:t>
             </a:r>
             <a:endParaRPr lang="en-US" sz="3000" dirty="0"/>
           </a:p>
@@ -4395,7 +4395,7 @@
                   <a:schemeClr val="tx2"/>
                 </a:solidFill>
               </a:rPr>
-              <a:t>Conclusiones: qué funciona y qué no</a:t>
+              <a:t>Conclusiones</a:t>
             </a:r>
             <a:endParaRPr lang="en-US" sz="3000" dirty="0"/>
           </a:p>
@@ -5573,7 +5573,7 @@
                   <a:schemeClr val="tx2"/>
                 </a:solidFill>
               </a:rPr>
-              <a:t>Andromeda: el creativo define la audiencia</a:t>
+              <a:t>Andromeda</a:t>
             </a:r>
             <a:endParaRPr lang="en-US" sz="3000" dirty="0"/>
           </a:p>

</xml_diff>